<commit_message>
Petiminutova prezentace bez Morphu, jen prolnuti
Co-Authored-By: Claude Opus 5.5 <noreply@anthropic.com>
</commit_message>
<xml_diff>
--- a/prezentace/KAM_Popojedem_5min.pptx
+++ b/prezentace/KAM_Popojedem_5min.pptx
@@ -4368,8 +4368,8 @@
   </p:clrMapOvr>
   <mc:AlternateContent xmlns:mc="http://schemas.openxmlformats.org/markup-compatibility/2006" xmlns:p14="http://schemas.microsoft.com/office/powerpoint/2010/main" xmlns:p159="http://schemas.microsoft.com/office/powerpoint/2015/09/main">
     <mc:Choice Requires="p159">
-      <p:transition spd="slow" p14:dur="1600">
-        <p159:morph option="byObject"/>
+      <p:transition spd="slow" p14:dur="1000">
+        <p:fade/>
       </p:transition>
     </mc:Choice>
     <mc:Fallback>
@@ -5203,8 +5203,8 @@
   </p:clrMapOvr>
   <mc:AlternateContent xmlns:mc="http://schemas.openxmlformats.org/markup-compatibility/2006" xmlns:p14="http://schemas.microsoft.com/office/powerpoint/2010/main" xmlns:p159="http://schemas.microsoft.com/office/powerpoint/2015/09/main">
     <mc:Choice Requires="p159">
-      <p:transition spd="slow" p14:dur="1600">
-        <p159:morph option="byObject"/>
+      <p:transition spd="slow" p14:dur="1000">
+        <p:fade/>
       </p:transition>
     </mc:Choice>
     <mc:Fallback>
@@ -5827,8 +5827,8 @@
   </p:clrMapOvr>
   <mc:AlternateContent xmlns:mc="http://schemas.openxmlformats.org/markup-compatibility/2006" xmlns:p14="http://schemas.microsoft.com/office/powerpoint/2010/main" xmlns:p159="http://schemas.microsoft.com/office/powerpoint/2015/09/main">
     <mc:Choice Requires="p159">
-      <p:transition spd="slow" p14:dur="1600">
-        <p159:morph option="byObject"/>
+      <p:transition spd="slow" p14:dur="1000">
+        <p:fade/>
       </p:transition>
     </mc:Choice>
     <mc:Fallback>
@@ -6545,8 +6545,8 @@
   </p:clrMapOvr>
   <mc:AlternateContent xmlns:mc="http://schemas.openxmlformats.org/markup-compatibility/2006" xmlns:p14="http://schemas.microsoft.com/office/powerpoint/2010/main" xmlns:p159="http://schemas.microsoft.com/office/powerpoint/2015/09/main">
     <mc:Choice Requires="p159">
-      <p:transition spd="slow" p14:dur="1600">
-        <p159:morph option="byObject"/>
+      <p:transition spd="slow" p14:dur="1000">
+        <p:fade/>
       </p:transition>
     </mc:Choice>
     <mc:Fallback>

</xml_diff>